<commit_message>
feat(video): add narrated HD video demo walkthrough, generator script, and interactive web video player
</commit_message>
<xml_diff>
--- a/FRYDAY_Amazon_Operations_AI_Agent_Presentation.pptx
+++ b/FRYDAY_Amazon_Operations_AI_Agent_Presentation.pptx
@@ -1,24 +1,24 @@
 
 <file path=ppt/presentation.xml><?xml version="1.0" encoding="utf-8"?>
-<p:presentation xmlns:a="http://schemas.openxmlformats.org/drawingml/2006/main" xmlns:r="http://schemas.openxmlformats.org/officeDocument/2006/relationships" xmlns:p="http://schemas.openxmlformats.org/presentationml/2006/main" saveSubsetFonts="1" autoCompressPictures="0">
+<p:presentation xmlns:a="http://schemas.openxmlformats.org/drawingml/2006/main" xmlns:r="http://schemas.openxmlformats.org/officeDocument/2006/relationships" xmlns:p="http://schemas.openxmlformats.org/presentationml/2006/main" autoCompressPictures="0">
   <p:sldMasterIdLst>
     <p:sldMasterId id="2147483648" r:id="rId1"/>
   </p:sldMasterIdLst>
   <p:sldIdLst>
-    <p:sldId id="256" r:id="rId7"/>
-    <p:sldId id="257" r:id="rId8"/>
-    <p:sldId id="258" r:id="rId9"/>
-    <p:sldId id="259" r:id="rId10"/>
-    <p:sldId id="260" r:id="rId11"/>
-    <p:sldId id="261" r:id="rId12"/>
-    <p:sldId id="262" r:id="rId13"/>
-    <p:sldId id="263" r:id="rId14"/>
-    <p:sldId id="264" r:id="rId15"/>
-    <p:sldId id="265" r:id="rId16"/>
-    <p:sldId id="266" r:id="rId17"/>
-    <p:sldId id="267" r:id="rId18"/>
+    <p:sldId id="256" r:id="rId3"/>
+    <p:sldId id="257" r:id="rId4"/>
+    <p:sldId id="258" r:id="rId5"/>
+    <p:sldId id="259" r:id="rId6"/>
+    <p:sldId id="260" r:id="rId7"/>
+    <p:sldId id="261" r:id="rId8"/>
+    <p:sldId id="262" r:id="rId9"/>
+    <p:sldId id="263" r:id="rId10"/>
+    <p:sldId id="264" r:id="rId11"/>
+    <p:sldId id="265" r:id="rId12"/>
+    <p:sldId id="266" r:id="rId13"/>
+    <p:sldId id="267" r:id="rId14"/>
   </p:sldIdLst>
-  <p:sldSz cx="12191695" cy="6858000" type="screen4x3"/>
+  <p:sldSz cx="12191365" cy="6858000" type="screen4x3"/>
   <p:notesSz cx="6858000" cy="9144000"/>
   <p:defaultTextStyle>
     <a:defPPr>
@@ -115,6 +115,22 @@
       </a:defRPr>
     </a:lvl9pPr>
   </p:defaultTextStyle>
+  <p:extLst>
+    <p:ext uri="{EFAFB233-063F-42B5-8137-9DF3F51BA10A}">
+      <p15:sldGuideLst xmlns:p15="http://schemas.microsoft.com/office/powerpoint/2012/main">
+        <p15:guide id="1" orient="horz" pos="2160" userDrawn="1">
+          <p15:clr>
+            <a:srgbClr val="A4A3A4"/>
+          </p15:clr>
+        </p15:guide>
+        <p15:guide id="2" pos="2880" userDrawn="1">
+          <p15:clr>
+            <a:srgbClr val="A4A3A4"/>
+          </p15:clr>
+        </p15:guide>
+      </p15:sldGuideLst>
+    </p:ext>
+  </p:extLst>
 </p:presentation>
 </file>
 
@@ -299,7 +315,6 @@
           <a:p>
             <a:fld id="{5BCAD085-E8A6-8845-BD4E-CB4CCA059FC4}" type="datetimeFigureOut">
               <a:rPr lang="en-US" smtClean="0"/>
-              <a:t>1/27/13</a:t>
             </a:fld>
             <a:endParaRPr lang="en-US"/>
           </a:p>
@@ -341,18 +356,12 @@
           <a:p>
             <a:fld id="{C1FF6DA9-008F-8B48-92A6-B652298478BF}" type="slidenum">
               <a:rPr lang="en-US" smtClean="0"/>
-              <a:t>‹#›</a:t>
             </a:fld>
             <a:endParaRPr lang="en-US"/>
           </a:p>
         </p:txBody>
       </p:sp>
     </p:spTree>
-    <p:extLst>
-      <p:ext uri="{BB962C8B-B14F-4D97-AF65-F5344CB8AC3E}">
-        <p14:creationId xmlns:p14="http://schemas.microsoft.com/office/powerpoint/2010/main" val="3168075583"/>
-      </p:ext>
-    </p:extLst>
   </p:cSld>
   <p:clrMapOvr>
     <a:masterClrMapping/>
@@ -420,6 +429,7 @@
               <a:rPr lang="en-US" smtClean="0"/>
               <a:t>Click to edit Master text styles</a:t>
             </a:r>
+            <a:endParaRPr lang="en-US" smtClean="0"/>
           </a:p>
           <a:p>
             <a:pPr lvl="1"/>
@@ -427,6 +437,7 @@
               <a:rPr lang="en-US" smtClean="0"/>
               <a:t>Second level</a:t>
             </a:r>
+            <a:endParaRPr lang="en-US" smtClean="0"/>
           </a:p>
           <a:p>
             <a:pPr lvl="2"/>
@@ -434,6 +445,7 @@
               <a:rPr lang="en-US" smtClean="0"/>
               <a:t>Third level</a:t>
             </a:r>
+            <a:endParaRPr lang="en-US" smtClean="0"/>
           </a:p>
           <a:p>
             <a:pPr lvl="3"/>
@@ -441,6 +453,7 @@
               <a:rPr lang="en-US" smtClean="0"/>
               <a:t>Fourth level</a:t>
             </a:r>
+            <a:endParaRPr lang="en-US" smtClean="0"/>
           </a:p>
           <a:p>
             <a:pPr lvl="4"/>
@@ -469,7 +482,6 @@
           <a:p>
             <a:fld id="{5BCAD085-E8A6-8845-BD4E-CB4CCA059FC4}" type="datetimeFigureOut">
               <a:rPr lang="en-US" smtClean="0"/>
-              <a:t>1/27/13</a:t>
             </a:fld>
             <a:endParaRPr lang="en-US"/>
           </a:p>
@@ -511,18 +523,12 @@
           <a:p>
             <a:fld id="{C1FF6DA9-008F-8B48-92A6-B652298478BF}" type="slidenum">
               <a:rPr lang="en-US" smtClean="0"/>
-              <a:t>‹#›</a:t>
             </a:fld>
             <a:endParaRPr lang="en-US"/>
           </a:p>
         </p:txBody>
       </p:sp>
     </p:spTree>
-    <p:extLst>
-      <p:ext uri="{BB962C8B-B14F-4D97-AF65-F5344CB8AC3E}">
-        <p14:creationId xmlns:p14="http://schemas.microsoft.com/office/powerpoint/2010/main" val="2910927964"/>
-      </p:ext>
-    </p:extLst>
   </p:cSld>
   <p:clrMapOvr>
     <a:masterClrMapping/>
@@ -600,6 +606,7 @@
               <a:rPr lang="en-US" smtClean="0"/>
               <a:t>Click to edit Master text styles</a:t>
             </a:r>
+            <a:endParaRPr lang="en-US" smtClean="0"/>
           </a:p>
           <a:p>
             <a:pPr lvl="1"/>
@@ -607,6 +614,7 @@
               <a:rPr lang="en-US" smtClean="0"/>
               <a:t>Second level</a:t>
             </a:r>
+            <a:endParaRPr lang="en-US" smtClean="0"/>
           </a:p>
           <a:p>
             <a:pPr lvl="2"/>
@@ -614,6 +622,7 @@
               <a:rPr lang="en-US" smtClean="0"/>
               <a:t>Third level</a:t>
             </a:r>
+            <a:endParaRPr lang="en-US" smtClean="0"/>
           </a:p>
           <a:p>
             <a:pPr lvl="3"/>
@@ -621,6 +630,7 @@
               <a:rPr lang="en-US" smtClean="0"/>
               <a:t>Fourth level</a:t>
             </a:r>
+            <a:endParaRPr lang="en-US" smtClean="0"/>
           </a:p>
           <a:p>
             <a:pPr lvl="4"/>
@@ -649,7 +659,6 @@
           <a:p>
             <a:fld id="{5BCAD085-E8A6-8845-BD4E-CB4CCA059FC4}" type="datetimeFigureOut">
               <a:rPr lang="en-US" smtClean="0"/>
-              <a:t>1/27/13</a:t>
             </a:fld>
             <a:endParaRPr lang="en-US"/>
           </a:p>
@@ -691,18 +700,12 @@
           <a:p>
             <a:fld id="{C1FF6DA9-008F-8B48-92A6-B652298478BF}" type="slidenum">
               <a:rPr lang="en-US" smtClean="0"/>
-              <a:t>‹#›</a:t>
             </a:fld>
             <a:endParaRPr lang="en-US"/>
           </a:p>
         </p:txBody>
       </p:sp>
     </p:spTree>
-    <p:extLst>
-      <p:ext uri="{BB962C8B-B14F-4D97-AF65-F5344CB8AC3E}">
-        <p14:creationId xmlns:p14="http://schemas.microsoft.com/office/powerpoint/2010/main" val="3612223792"/>
-      </p:ext>
-    </p:extLst>
   </p:cSld>
   <p:clrMapOvr>
     <a:masterClrMapping/>
@@ -770,6 +773,7 @@
               <a:rPr lang="en-US" smtClean="0"/>
               <a:t>Click to edit Master text styles</a:t>
             </a:r>
+            <a:endParaRPr lang="en-US" smtClean="0"/>
           </a:p>
           <a:p>
             <a:pPr lvl="1"/>
@@ -777,6 +781,7 @@
               <a:rPr lang="en-US" smtClean="0"/>
               <a:t>Second level</a:t>
             </a:r>
+            <a:endParaRPr lang="en-US" smtClean="0"/>
           </a:p>
           <a:p>
             <a:pPr lvl="2"/>
@@ -784,6 +789,7 @@
               <a:rPr lang="en-US" smtClean="0"/>
               <a:t>Third level</a:t>
             </a:r>
+            <a:endParaRPr lang="en-US" smtClean="0"/>
           </a:p>
           <a:p>
             <a:pPr lvl="3"/>
@@ -791,6 +797,7 @@
               <a:rPr lang="en-US" smtClean="0"/>
               <a:t>Fourth level</a:t>
             </a:r>
+            <a:endParaRPr lang="en-US" smtClean="0"/>
           </a:p>
           <a:p>
             <a:pPr lvl="4"/>
@@ -819,7 +826,6 @@
           <a:p>
             <a:fld id="{5BCAD085-E8A6-8845-BD4E-CB4CCA059FC4}" type="datetimeFigureOut">
               <a:rPr lang="en-US" smtClean="0"/>
-              <a:t>1/27/13</a:t>
             </a:fld>
             <a:endParaRPr lang="en-US"/>
           </a:p>
@@ -861,18 +867,12 @@
           <a:p>
             <a:fld id="{C1FF6DA9-008F-8B48-92A6-B652298478BF}" type="slidenum">
               <a:rPr lang="en-US" smtClean="0"/>
-              <a:t>‹#›</a:t>
             </a:fld>
             <a:endParaRPr lang="en-US"/>
           </a:p>
         </p:txBody>
       </p:sp>
     </p:spTree>
-    <p:extLst>
-      <p:ext uri="{BB962C8B-B14F-4D97-AF65-F5344CB8AC3E}">
-        <p14:creationId xmlns:p14="http://schemas.microsoft.com/office/powerpoint/2010/main" val="2614314258"/>
-      </p:ext>
-    </p:extLst>
   </p:cSld>
   <p:clrMapOvr>
     <a:masterClrMapping/>
@@ -1045,6 +1045,7 @@
               <a:rPr lang="en-US" smtClean="0"/>
               <a:t>Click to edit Master text styles</a:t>
             </a:r>
+            <a:endParaRPr lang="en-US" smtClean="0"/>
           </a:p>
         </p:txBody>
       </p:sp>
@@ -1065,7 +1066,6 @@
           <a:p>
             <a:fld id="{5BCAD085-E8A6-8845-BD4E-CB4CCA059FC4}" type="datetimeFigureOut">
               <a:rPr lang="en-US" smtClean="0"/>
-              <a:t>1/27/13</a:t>
             </a:fld>
             <a:endParaRPr lang="en-US"/>
           </a:p>
@@ -1107,18 +1107,12 @@
           <a:p>
             <a:fld id="{C1FF6DA9-008F-8B48-92A6-B652298478BF}" type="slidenum">
               <a:rPr lang="en-US" smtClean="0"/>
-              <a:t>‹#›</a:t>
             </a:fld>
             <a:endParaRPr lang="en-US"/>
           </a:p>
         </p:txBody>
       </p:sp>
     </p:spTree>
-    <p:extLst>
-      <p:ext uri="{BB962C8B-B14F-4D97-AF65-F5344CB8AC3E}">
-        <p14:creationId xmlns:p14="http://schemas.microsoft.com/office/powerpoint/2010/main" val="960648375"/>
-      </p:ext>
-    </p:extLst>
   </p:cSld>
   <p:clrMapOvr>
     <a:masterClrMapping/>
@@ -1219,6 +1213,7 @@
               <a:rPr lang="en-US" smtClean="0"/>
               <a:t>Click to edit Master text styles</a:t>
             </a:r>
+            <a:endParaRPr lang="en-US" smtClean="0"/>
           </a:p>
           <a:p>
             <a:pPr lvl="1"/>
@@ -1226,6 +1221,7 @@
               <a:rPr lang="en-US" smtClean="0"/>
               <a:t>Second level</a:t>
             </a:r>
+            <a:endParaRPr lang="en-US" smtClean="0"/>
           </a:p>
           <a:p>
             <a:pPr lvl="2"/>
@@ -1233,6 +1229,7 @@
               <a:rPr lang="en-US" smtClean="0"/>
               <a:t>Third level</a:t>
             </a:r>
+            <a:endParaRPr lang="en-US" smtClean="0"/>
           </a:p>
           <a:p>
             <a:pPr lvl="3"/>
@@ -1240,6 +1237,7 @@
               <a:rPr lang="en-US" smtClean="0"/>
               <a:t>Fourth level</a:t>
             </a:r>
+            <a:endParaRPr lang="en-US" smtClean="0"/>
           </a:p>
           <a:p>
             <a:pPr lvl="4"/>
@@ -1304,6 +1302,7 @@
               <a:rPr lang="en-US" smtClean="0"/>
               <a:t>Click to edit Master text styles</a:t>
             </a:r>
+            <a:endParaRPr lang="en-US" smtClean="0"/>
           </a:p>
           <a:p>
             <a:pPr lvl="1"/>
@@ -1311,6 +1310,7 @@
               <a:rPr lang="en-US" smtClean="0"/>
               <a:t>Second level</a:t>
             </a:r>
+            <a:endParaRPr lang="en-US" smtClean="0"/>
           </a:p>
           <a:p>
             <a:pPr lvl="2"/>
@@ -1318,6 +1318,7 @@
               <a:rPr lang="en-US" smtClean="0"/>
               <a:t>Third level</a:t>
             </a:r>
+            <a:endParaRPr lang="en-US" smtClean="0"/>
           </a:p>
           <a:p>
             <a:pPr lvl="3"/>
@@ -1325,6 +1326,7 @@
               <a:rPr lang="en-US" smtClean="0"/>
               <a:t>Fourth level</a:t>
             </a:r>
+            <a:endParaRPr lang="en-US" smtClean="0"/>
           </a:p>
           <a:p>
             <a:pPr lvl="4"/>
@@ -1353,7 +1355,6 @@
           <a:p>
             <a:fld id="{5BCAD085-E8A6-8845-BD4E-CB4CCA059FC4}" type="datetimeFigureOut">
               <a:rPr lang="en-US" smtClean="0"/>
-              <a:t>1/27/13</a:t>
             </a:fld>
             <a:endParaRPr lang="en-US"/>
           </a:p>
@@ -1395,18 +1396,12 @@
           <a:p>
             <a:fld id="{C1FF6DA9-008F-8B48-92A6-B652298478BF}" type="slidenum">
               <a:rPr lang="en-US" smtClean="0"/>
-              <a:t>‹#›</a:t>
             </a:fld>
             <a:endParaRPr lang="en-US"/>
           </a:p>
         </p:txBody>
       </p:sp>
     </p:spTree>
-    <p:extLst>
-      <p:ext uri="{BB962C8B-B14F-4D97-AF65-F5344CB8AC3E}">
-        <p14:creationId xmlns:p14="http://schemas.microsoft.com/office/powerpoint/2010/main" val="2782244947"/>
-      </p:ext>
-    </p:extLst>
   </p:cSld>
   <p:clrMapOvr>
     <a:masterClrMapping/>
@@ -1520,6 +1515,7 @@
               <a:rPr lang="en-US" smtClean="0"/>
               <a:t>Click to edit Master text styles</a:t>
             </a:r>
+            <a:endParaRPr lang="en-US" smtClean="0"/>
           </a:p>
         </p:txBody>
       </p:sp>
@@ -1576,6 +1572,7 @@
               <a:rPr lang="en-US" smtClean="0"/>
               <a:t>Click to edit Master text styles</a:t>
             </a:r>
+            <a:endParaRPr lang="en-US" smtClean="0"/>
           </a:p>
           <a:p>
             <a:pPr lvl="1"/>
@@ -1583,6 +1580,7 @@
               <a:rPr lang="en-US" smtClean="0"/>
               <a:t>Second level</a:t>
             </a:r>
+            <a:endParaRPr lang="en-US" smtClean="0"/>
           </a:p>
           <a:p>
             <a:pPr lvl="2"/>
@@ -1590,6 +1588,7 @@
               <a:rPr lang="en-US" smtClean="0"/>
               <a:t>Third level</a:t>
             </a:r>
+            <a:endParaRPr lang="en-US" smtClean="0"/>
           </a:p>
           <a:p>
             <a:pPr lvl="3"/>
@@ -1597,6 +1596,7 @@
               <a:rPr lang="en-US" smtClean="0"/>
               <a:t>Fourth level</a:t>
             </a:r>
+            <a:endParaRPr lang="en-US" smtClean="0"/>
           </a:p>
           <a:p>
             <a:pPr lvl="4"/>
@@ -1670,6 +1670,7 @@
               <a:rPr lang="en-US" smtClean="0"/>
               <a:t>Click to edit Master text styles</a:t>
             </a:r>
+            <a:endParaRPr lang="en-US" smtClean="0"/>
           </a:p>
         </p:txBody>
       </p:sp>
@@ -1726,6 +1727,7 @@
               <a:rPr lang="en-US" smtClean="0"/>
               <a:t>Click to edit Master text styles</a:t>
             </a:r>
+            <a:endParaRPr lang="en-US" smtClean="0"/>
           </a:p>
           <a:p>
             <a:pPr lvl="1"/>
@@ -1733,6 +1735,7 @@
               <a:rPr lang="en-US" smtClean="0"/>
               <a:t>Second level</a:t>
             </a:r>
+            <a:endParaRPr lang="en-US" smtClean="0"/>
           </a:p>
           <a:p>
             <a:pPr lvl="2"/>
@@ -1740,6 +1743,7 @@
               <a:rPr lang="en-US" smtClean="0"/>
               <a:t>Third level</a:t>
             </a:r>
+            <a:endParaRPr lang="en-US" smtClean="0"/>
           </a:p>
           <a:p>
             <a:pPr lvl="3"/>
@@ -1747,6 +1751,7 @@
               <a:rPr lang="en-US" smtClean="0"/>
               <a:t>Fourth level</a:t>
             </a:r>
+            <a:endParaRPr lang="en-US" smtClean="0"/>
           </a:p>
           <a:p>
             <a:pPr lvl="4"/>
@@ -1775,7 +1780,6 @@
           <a:p>
             <a:fld id="{5BCAD085-E8A6-8845-BD4E-CB4CCA059FC4}" type="datetimeFigureOut">
               <a:rPr lang="en-US" smtClean="0"/>
-              <a:t>1/27/13</a:t>
             </a:fld>
             <a:endParaRPr lang="en-US"/>
           </a:p>
@@ -1817,18 +1821,12 @@
           <a:p>
             <a:fld id="{C1FF6DA9-008F-8B48-92A6-B652298478BF}" type="slidenum">
               <a:rPr lang="en-US" smtClean="0"/>
-              <a:t>‹#›</a:t>
             </a:fld>
             <a:endParaRPr lang="en-US"/>
           </a:p>
         </p:txBody>
       </p:sp>
     </p:spTree>
-    <p:extLst>
-      <p:ext uri="{BB962C8B-B14F-4D97-AF65-F5344CB8AC3E}">
-        <p14:creationId xmlns:p14="http://schemas.microsoft.com/office/powerpoint/2010/main" val="990158736"/>
-      </p:ext>
-    </p:extLst>
   </p:cSld>
   <p:clrMapOvr>
     <a:masterClrMapping/>
@@ -1893,7 +1891,6 @@
           <a:p>
             <a:fld id="{5BCAD085-E8A6-8845-BD4E-CB4CCA059FC4}" type="datetimeFigureOut">
               <a:rPr lang="en-US" smtClean="0"/>
-              <a:t>1/27/13</a:t>
             </a:fld>
             <a:endParaRPr lang="en-US"/>
           </a:p>
@@ -1935,18 +1932,12 @@
           <a:p>
             <a:fld id="{C1FF6DA9-008F-8B48-92A6-B652298478BF}" type="slidenum">
               <a:rPr lang="en-US" smtClean="0"/>
-              <a:t>‹#›</a:t>
             </a:fld>
             <a:endParaRPr lang="en-US"/>
           </a:p>
         </p:txBody>
       </p:sp>
     </p:spTree>
-    <p:extLst>
-      <p:ext uri="{BB962C8B-B14F-4D97-AF65-F5344CB8AC3E}">
-        <p14:creationId xmlns:p14="http://schemas.microsoft.com/office/powerpoint/2010/main" val="727027711"/>
-      </p:ext>
-    </p:extLst>
   </p:cSld>
   <p:clrMapOvr>
     <a:masterClrMapping/>
@@ -1988,7 +1979,6 @@
           <a:p>
             <a:fld id="{5BCAD085-E8A6-8845-BD4E-CB4CCA059FC4}" type="datetimeFigureOut">
               <a:rPr lang="en-US" smtClean="0"/>
-              <a:t>1/27/13</a:t>
             </a:fld>
             <a:endParaRPr lang="en-US"/>
           </a:p>
@@ -2030,18 +2020,12 @@
           <a:p>
             <a:fld id="{C1FF6DA9-008F-8B48-92A6-B652298478BF}" type="slidenum">
               <a:rPr lang="en-US" smtClean="0"/>
-              <a:t>‹#›</a:t>
             </a:fld>
             <a:endParaRPr lang="en-US"/>
           </a:p>
         </p:txBody>
       </p:sp>
     </p:spTree>
-    <p:extLst>
-      <p:ext uri="{BB962C8B-B14F-4D97-AF65-F5344CB8AC3E}">
-        <p14:creationId xmlns:p14="http://schemas.microsoft.com/office/powerpoint/2010/main" val="1212999818"/>
-      </p:ext>
-    </p:extLst>
   </p:cSld>
   <p:clrMapOvr>
     <a:masterClrMapping/>
@@ -2151,6 +2135,7 @@
               <a:rPr lang="en-US" smtClean="0"/>
               <a:t>Click to edit Master text styles</a:t>
             </a:r>
+            <a:endParaRPr lang="en-US" smtClean="0"/>
           </a:p>
           <a:p>
             <a:pPr lvl="1"/>
@@ -2158,6 +2143,7 @@
               <a:rPr lang="en-US" smtClean="0"/>
               <a:t>Second level</a:t>
             </a:r>
+            <a:endParaRPr lang="en-US" smtClean="0"/>
           </a:p>
           <a:p>
             <a:pPr lvl="2"/>
@@ -2165,6 +2151,7 @@
               <a:rPr lang="en-US" smtClean="0"/>
               <a:t>Third level</a:t>
             </a:r>
+            <a:endParaRPr lang="en-US" smtClean="0"/>
           </a:p>
           <a:p>
             <a:pPr lvl="3"/>
@@ -2172,6 +2159,7 @@
               <a:rPr lang="en-US" smtClean="0"/>
               <a:t>Fourth level</a:t>
             </a:r>
+            <a:endParaRPr lang="en-US" smtClean="0"/>
           </a:p>
           <a:p>
             <a:pPr lvl="4"/>
@@ -2245,6 +2233,7 @@
               <a:rPr lang="en-US" smtClean="0"/>
               <a:t>Click to edit Master text styles</a:t>
             </a:r>
+            <a:endParaRPr lang="en-US" smtClean="0"/>
           </a:p>
         </p:txBody>
       </p:sp>
@@ -2265,7 +2254,6 @@
           <a:p>
             <a:fld id="{5BCAD085-E8A6-8845-BD4E-CB4CCA059FC4}" type="datetimeFigureOut">
               <a:rPr lang="en-US" smtClean="0"/>
-              <a:t>1/27/13</a:t>
             </a:fld>
             <a:endParaRPr lang="en-US"/>
           </a:p>
@@ -2307,18 +2295,12 @@
           <a:p>
             <a:fld id="{C1FF6DA9-008F-8B48-92A6-B652298478BF}" type="slidenum">
               <a:rPr lang="en-US" smtClean="0"/>
-              <a:t>‹#›</a:t>
             </a:fld>
             <a:endParaRPr lang="en-US"/>
           </a:p>
         </p:txBody>
       </p:sp>
     </p:spTree>
-    <p:extLst>
-      <p:ext uri="{BB962C8B-B14F-4D97-AF65-F5344CB8AC3E}">
-        <p14:creationId xmlns:p14="http://schemas.microsoft.com/office/powerpoint/2010/main" val="1840726560"/>
-      </p:ext>
-    </p:extLst>
   </p:cSld>
   <p:clrMapOvr>
     <a:masterClrMapping/>
@@ -2498,6 +2480,7 @@
               <a:rPr lang="en-US" smtClean="0"/>
               <a:t>Click to edit Master text styles</a:t>
             </a:r>
+            <a:endParaRPr lang="en-US" smtClean="0"/>
           </a:p>
         </p:txBody>
       </p:sp>
@@ -2518,7 +2501,6 @@
           <a:p>
             <a:fld id="{5BCAD085-E8A6-8845-BD4E-CB4CCA059FC4}" type="datetimeFigureOut">
               <a:rPr lang="en-US" smtClean="0"/>
-              <a:t>1/27/13</a:t>
             </a:fld>
             <a:endParaRPr lang="en-US"/>
           </a:p>
@@ -2560,18 +2542,12 @@
           <a:p>
             <a:fld id="{C1FF6DA9-008F-8B48-92A6-B652298478BF}" type="slidenum">
               <a:rPr lang="en-US" smtClean="0"/>
-              <a:t>‹#›</a:t>
             </a:fld>
             <a:endParaRPr lang="en-US"/>
           </a:p>
         </p:txBody>
       </p:sp>
     </p:spTree>
-    <p:extLst>
-      <p:ext uri="{BB962C8B-B14F-4D97-AF65-F5344CB8AC3E}">
-        <p14:creationId xmlns:p14="http://schemas.microsoft.com/office/powerpoint/2010/main" val="3889236939"/>
-      </p:ext>
-    </p:extLst>
   </p:cSld>
   <p:clrMapOvr>
     <a:masterClrMapping/>
@@ -2664,6 +2640,7 @@
               <a:rPr lang="en-US" smtClean="0"/>
               <a:t>Click to edit Master text styles</a:t>
             </a:r>
+            <a:endParaRPr lang="en-US" smtClean="0"/>
           </a:p>
           <a:p>
             <a:pPr lvl="1"/>
@@ -2671,6 +2648,7 @@
               <a:rPr lang="en-US" smtClean="0"/>
               <a:t>Second level</a:t>
             </a:r>
+            <a:endParaRPr lang="en-US" smtClean="0"/>
           </a:p>
           <a:p>
             <a:pPr lvl="2"/>
@@ -2678,6 +2656,7 @@
               <a:rPr lang="en-US" smtClean="0"/>
               <a:t>Third level</a:t>
             </a:r>
+            <a:endParaRPr lang="en-US" smtClean="0"/>
           </a:p>
           <a:p>
             <a:pPr lvl="3"/>
@@ -2685,6 +2664,7 @@
               <a:rPr lang="en-US" smtClean="0"/>
               <a:t>Fourth level</a:t>
             </a:r>
+            <a:endParaRPr lang="en-US" smtClean="0"/>
           </a:p>
           <a:p>
             <a:pPr lvl="4"/>
@@ -2731,7 +2711,6 @@
           <a:p>
             <a:fld id="{5BCAD085-E8A6-8845-BD4E-CB4CCA059FC4}" type="datetimeFigureOut">
               <a:rPr lang="en-US" smtClean="0"/>
-              <a:t>1/27/13</a:t>
             </a:fld>
             <a:endParaRPr lang="en-US"/>
           </a:p>
@@ -2809,18 +2788,12 @@
           <a:p>
             <a:fld id="{C1FF6DA9-008F-8B48-92A6-B652298478BF}" type="slidenum">
               <a:rPr lang="en-US" smtClean="0"/>
-              <a:t>‹#›</a:t>
             </a:fld>
             <a:endParaRPr lang="en-US"/>
           </a:p>
         </p:txBody>
       </p:sp>
     </p:spTree>
-    <p:extLst>
-      <p:ext uri="{BB962C8B-B14F-4D97-AF65-F5344CB8AC3E}">
-        <p14:creationId xmlns:p14="http://schemas.microsoft.com/office/powerpoint/2010/main" val="2209977519"/>
-      </p:ext>
-    </p:extLst>
   </p:cSld>
   <p:clrMap bg1="lt1" tx1="dk1" bg2="lt2" tx2="dk2" accent1="accent1" accent2="accent2" accent3="accent3" accent4="accent4" accent5="accent5" accent6="accent6" hlink="hlink" folHlink="folHlink"/>
   <p:sldLayoutIdLst>
@@ -2858,7 +2831,7 @@
         <a:spcBef>
           <a:spcPct val="20000"/>
         </a:spcBef>
-        <a:buFont typeface="Arial"/>
+        <a:buFont typeface="Arial" panose="020B0604020202020204"/>
         <a:buChar char="•"/>
         <a:defRPr sz="3200" kern="1200">
           <a:solidFill>
@@ -2873,7 +2846,7 @@
         <a:spcBef>
           <a:spcPct val="20000"/>
         </a:spcBef>
-        <a:buFont typeface="Arial"/>
+        <a:buFont typeface="Arial" panose="020B0604020202020204"/>
         <a:buChar char="–"/>
         <a:defRPr sz="2800" kern="1200">
           <a:solidFill>
@@ -2888,7 +2861,7 @@
         <a:spcBef>
           <a:spcPct val="20000"/>
         </a:spcBef>
-        <a:buFont typeface="Arial"/>
+        <a:buFont typeface="Arial" panose="020B0604020202020204"/>
         <a:buChar char="•"/>
         <a:defRPr sz="2400" kern="1200">
           <a:solidFill>
@@ -2903,7 +2876,7 @@
         <a:spcBef>
           <a:spcPct val="20000"/>
         </a:spcBef>
-        <a:buFont typeface="Arial"/>
+        <a:buFont typeface="Arial" panose="020B0604020202020204"/>
         <a:buChar char="–"/>
         <a:defRPr sz="2000" kern="1200">
           <a:solidFill>
@@ -2918,7 +2891,7 @@
         <a:spcBef>
           <a:spcPct val="20000"/>
         </a:spcBef>
-        <a:buFont typeface="Arial"/>
+        <a:buFont typeface="Arial" panose="020B0604020202020204"/>
         <a:buChar char="»"/>
         <a:defRPr sz="2000" kern="1200">
           <a:solidFill>
@@ -2933,7 +2906,7 @@
         <a:spcBef>
           <a:spcPct val="20000"/>
         </a:spcBef>
-        <a:buFont typeface="Arial"/>
+        <a:buFont typeface="Arial" panose="020B0604020202020204"/>
         <a:buChar char="•"/>
         <a:defRPr sz="2000" kern="1200">
           <a:solidFill>
@@ -2948,7 +2921,7 @@
         <a:spcBef>
           <a:spcPct val="20000"/>
         </a:spcBef>
-        <a:buFont typeface="Arial"/>
+        <a:buFont typeface="Arial" panose="020B0604020202020204"/>
         <a:buChar char="•"/>
         <a:defRPr sz="2000" kern="1200">
           <a:solidFill>
@@ -2963,7 +2936,7 @@
         <a:spcBef>
           <a:spcPct val="20000"/>
         </a:spcBef>
-        <a:buFont typeface="Arial"/>
+        <a:buFont typeface="Arial" panose="020B0604020202020204"/>
         <a:buChar char="•"/>
         <a:defRPr sz="2000" kern="1200">
           <a:solidFill>
@@ -2978,7 +2951,7 @@
         <a:spcBef>
           <a:spcPct val="20000"/>
         </a:spcBef>
-        <a:buFont typeface="Arial"/>
+        <a:buFont typeface="Arial" panose="020B0604020202020204"/>
         <a:buChar char="•"/>
         <a:defRPr sz="2000" kern="1200">
           <a:solidFill>
@@ -3090,7 +3063,7 @@
 </file>
 
 <file path=ppt/slides/slide1.xml><?xml version="1.0" encoding="utf-8"?>
-<p:sld xmlns:a="http://schemas.openxmlformats.org/drawingml/2006/main" xmlns:p="http://schemas.openxmlformats.org/presentationml/2006/main" xmlns:r="http://schemas.openxmlformats.org/officeDocument/2006/relationships">
+<p:sld xmlns:a="http://schemas.openxmlformats.org/drawingml/2006/main" xmlns:r="http://schemas.openxmlformats.org/officeDocument/2006/relationships" xmlns:p="http://schemas.openxmlformats.org/presentationml/2006/main">
   <p:cSld>
     <p:spTree>
       <p:nvGrpSpPr>
@@ -3265,7 +3238,7 @@
         </p:nvSpPr>
         <p:spPr>
           <a:xfrm>
-            <a:off x="1645920" y="3017520"/>
+            <a:off x="1645920" y="3077845"/>
             <a:ext cx="8869680" cy="914400"/>
           </a:xfrm>
           <a:prstGeom prst="rect">
@@ -3294,14 +3267,14 @@
       </p:sp>
       <p:sp>
         <p:nvSpPr>
-          <p:cNvPr id="7" name="TextBox 6"/>
+          <p:cNvPr id="8" name="TextBox 7"/>
           <p:cNvSpPr txBox="1"/>
           <p:nvPr/>
         </p:nvSpPr>
         <p:spPr>
           <a:xfrm>
-            <a:off x="1645920" y="3931920"/>
-            <a:ext cx="8869680" cy="1097280"/>
+            <a:off x="1645920" y="5120640"/>
+            <a:ext cx="309880" cy="260350"/>
           </a:xfrm>
           <a:prstGeom prst="rect">
             <a:avLst/>
@@ -3315,50 +3288,12 @@
           <a:lstStyle/>
           <a:p>
             <a:pPr>
-              <a:defRPr sz="1300">
-                <a:solidFill>
-                  <a:srgbClr val="94A3B8"/>
-                </a:solidFill>
-              </a:defRPr>
-            </a:pPr>
-            <a:r>
-              <a:t>A multi-agent ReAct system engineered to solve actual operational bottlenecks for Amazon: auditing delivery delays, resolving FC conveyor jams, investigating customer concessions, detecting high-return defective ASINs, forecasting stockouts, and neutralizing concession fraud.</a:t>
-            </a:r>
-          </a:p>
-        </p:txBody>
-      </p:sp>
-      <p:sp>
-        <p:nvSpPr>
-          <p:cNvPr id="8" name="TextBox 7"/>
-          <p:cNvSpPr txBox="1"/>
-          <p:nvPr/>
-        </p:nvSpPr>
-        <p:spPr>
-          <a:xfrm>
-            <a:off x="1645920" y="5120640"/>
-            <a:ext cx="8869680" cy="457200"/>
-          </a:xfrm>
-          <a:prstGeom prst="rect">
-            <a:avLst/>
-          </a:prstGeom>
-          <a:noFill/>
-        </p:spPr>
-        <p:txBody>
-          <a:bodyPr wrap="none">
-            <a:spAutoFit/>
-          </a:bodyPr>
-          <a:lstStyle/>
-          <a:p>
-            <a:pPr>
               <a:defRPr sz="1100" b="1">
                 <a:solidFill>
                   <a:srgbClr val="38BDF8"/>
                 </a:solidFill>
               </a:defRPr>
             </a:pPr>
-            <a:r>
-              <a:t>Google Gemini 2.5 Flash  •  FastAPI + WebSockets  •  Hybrid Lexical/Semantic RAG  •  100% Automated Test Pass (47 Tests)</a:t>
-            </a:r>
           </a:p>
         </p:txBody>
       </p:sp>
@@ -3371,7 +3306,7 @@
 </file>
 
 <file path=ppt/slides/slide10.xml><?xml version="1.0" encoding="utf-8"?>
-<p:sld xmlns:a="http://schemas.openxmlformats.org/drawingml/2006/main" xmlns:p="http://schemas.openxmlformats.org/presentationml/2006/main" xmlns:r="http://schemas.openxmlformats.org/officeDocument/2006/relationships">
+<p:sld xmlns:a="http://schemas.openxmlformats.org/drawingml/2006/main" xmlns:r="http://schemas.openxmlformats.org/officeDocument/2006/relationships" xmlns:p="http://schemas.openxmlformats.org/presentationml/2006/main">
   <p:cSld>
     <p:spTree>
       <p:nvGrpSpPr>
@@ -3982,7 +3917,7 @@
 </file>
 
 <file path=ppt/slides/slide11.xml><?xml version="1.0" encoding="utf-8"?>
-<p:sld xmlns:a="http://schemas.openxmlformats.org/drawingml/2006/main" xmlns:p="http://schemas.openxmlformats.org/presentationml/2006/main" xmlns:r="http://schemas.openxmlformats.org/officeDocument/2006/relationships">
+<p:sld xmlns:a="http://schemas.openxmlformats.org/drawingml/2006/main" xmlns:r="http://schemas.openxmlformats.org/officeDocument/2006/relationships" xmlns:p="http://schemas.openxmlformats.org/presentationml/2006/main">
   <p:cSld>
     <p:spTree>
       <p:nvGrpSpPr>
@@ -4688,7 +4623,7 @@
 </file>
 
 <file path=ppt/slides/slide12.xml><?xml version="1.0" encoding="utf-8"?>
-<p:sld xmlns:a="http://schemas.openxmlformats.org/drawingml/2006/main" xmlns:p="http://schemas.openxmlformats.org/presentationml/2006/main" xmlns:r="http://schemas.openxmlformats.org/officeDocument/2006/relationships">
+<p:sld xmlns:a="http://schemas.openxmlformats.org/drawingml/2006/main" xmlns:r="http://schemas.openxmlformats.org/officeDocument/2006/relationships" xmlns:p="http://schemas.openxmlformats.org/presentationml/2006/main">
   <p:cSld>
     <p:spTree>
       <p:nvGrpSpPr>
@@ -4705,7 +4640,7 @@
         </p:nvSpPr>
         <p:spPr>
           <a:xfrm>
-            <a:off x="0" y="0"/>
+            <a:off x="341630" y="-210820"/>
             <a:ext cx="12191695" cy="6858000"/>
           </a:xfrm>
           <a:prstGeom prst="rect">
@@ -4794,7 +4729,7 @@
         <p:spPr>
           <a:xfrm>
             <a:off x="1828800" y="1463040"/>
-            <a:ext cx="8534095" cy="3931920"/>
+            <a:ext cx="8534095" cy="3799840"/>
           </a:xfrm>
           <a:prstGeom prst="rect">
             <a:avLst/>
@@ -4952,16 +4887,16 @@
             </a:r>
           </a:p>
           <a:p>
+            <a:pPr>
+              <a:defRPr sz="1600" b="1">
+                <a:solidFill>
+                  <a:srgbClr val="34D399"/>
+                </a:solidFill>
+              </a:defRPr>
+            </a:pPr>
             <a:br/>
-            <a:pPr>
-              <a:defRPr sz="1600" b="1">
-                <a:solidFill>
-                  <a:srgbClr val="34D399"/>
-                </a:solidFill>
-              </a:defRPr>
-            </a:pPr>
-            <a:r>
-              <a:t>Thank you! Questions &amp; Live Q&amp;A.</a:t>
+            <a:r>
+              <a:t>Thank you! </a:t>
             </a:r>
           </a:p>
         </p:txBody>
@@ -4975,7 +4910,7 @@
 </file>
 
 <file path=ppt/slides/slide2.xml><?xml version="1.0" encoding="utf-8"?>
-<p:sld xmlns:a="http://schemas.openxmlformats.org/drawingml/2006/main" xmlns:p="http://schemas.openxmlformats.org/presentationml/2006/main" xmlns:r="http://schemas.openxmlformats.org/officeDocument/2006/relationships">
+<p:sld xmlns:a="http://schemas.openxmlformats.org/drawingml/2006/main" xmlns:r="http://schemas.openxmlformats.org/officeDocument/2006/relationships" xmlns:p="http://schemas.openxmlformats.org/presentationml/2006/main">
   <p:cSld>
     <p:spTree>
       <p:nvGrpSpPr>
@@ -5501,7 +5436,7 @@
 </file>
 
 <file path=ppt/slides/slide3.xml><?xml version="1.0" encoding="utf-8"?>
-<p:sld xmlns:a="http://schemas.openxmlformats.org/drawingml/2006/main" xmlns:p="http://schemas.openxmlformats.org/presentationml/2006/main" xmlns:r="http://schemas.openxmlformats.org/officeDocument/2006/relationships">
+<p:sld xmlns:a="http://schemas.openxmlformats.org/drawingml/2006/main" xmlns:r="http://schemas.openxmlformats.org/officeDocument/2006/relationships" xmlns:p="http://schemas.openxmlformats.org/presentationml/2006/main">
   <p:cSld>
     <p:spTree>
       <p:nvGrpSpPr>
@@ -6203,7 +6138,7 @@
 </file>
 
 <file path=ppt/slides/slide4.xml><?xml version="1.0" encoding="utf-8"?>
-<p:sld xmlns:a="http://schemas.openxmlformats.org/drawingml/2006/main" xmlns:p="http://schemas.openxmlformats.org/presentationml/2006/main" xmlns:r="http://schemas.openxmlformats.org/officeDocument/2006/relationships">
+<p:sld xmlns:a="http://schemas.openxmlformats.org/drawingml/2006/main" xmlns:r="http://schemas.openxmlformats.org/officeDocument/2006/relationships" xmlns:p="http://schemas.openxmlformats.org/presentationml/2006/main">
   <p:cSld>
     <p:spTree>
       <p:nvGrpSpPr>
@@ -7205,7 +7140,7 @@
 </file>
 
 <file path=ppt/slides/slide5.xml><?xml version="1.0" encoding="utf-8"?>
-<p:sld xmlns:a="http://schemas.openxmlformats.org/drawingml/2006/main" xmlns:p="http://schemas.openxmlformats.org/presentationml/2006/main" xmlns:r="http://schemas.openxmlformats.org/officeDocument/2006/relationships">
+<p:sld xmlns:a="http://schemas.openxmlformats.org/drawingml/2006/main" xmlns:r="http://schemas.openxmlformats.org/officeDocument/2006/relationships" xmlns:p="http://schemas.openxmlformats.org/presentationml/2006/main">
   <p:cSld>
     <p:spTree>
       <p:nvGrpSpPr>
@@ -7802,7 +7737,7 @@
 </file>
 
 <file path=ppt/slides/slide6.xml><?xml version="1.0" encoding="utf-8"?>
-<p:sld xmlns:a="http://schemas.openxmlformats.org/drawingml/2006/main" xmlns:p="http://schemas.openxmlformats.org/presentationml/2006/main" xmlns:r="http://schemas.openxmlformats.org/officeDocument/2006/relationships">
+<p:sld xmlns:a="http://schemas.openxmlformats.org/drawingml/2006/main" xmlns:r="http://schemas.openxmlformats.org/officeDocument/2006/relationships" xmlns:p="http://schemas.openxmlformats.org/presentationml/2006/main">
   <p:cSld>
     <p:spTree>
       <p:nvGrpSpPr>
@@ -8360,7 +8295,7 @@
 </file>
 
 <file path=ppt/slides/slide7.xml><?xml version="1.0" encoding="utf-8"?>
-<p:sld xmlns:a="http://schemas.openxmlformats.org/drawingml/2006/main" xmlns:p="http://schemas.openxmlformats.org/presentationml/2006/main" xmlns:r="http://schemas.openxmlformats.org/officeDocument/2006/relationships">
+<p:sld xmlns:a="http://schemas.openxmlformats.org/drawingml/2006/main" xmlns:r="http://schemas.openxmlformats.org/officeDocument/2006/relationships" xmlns:p="http://schemas.openxmlformats.org/presentationml/2006/main">
   <p:cSld>
     <p:spTree>
       <p:nvGrpSpPr>
@@ -8918,7 +8853,7 @@
 </file>
 
 <file path=ppt/slides/slide8.xml><?xml version="1.0" encoding="utf-8"?>
-<p:sld xmlns:a="http://schemas.openxmlformats.org/drawingml/2006/main" xmlns:p="http://schemas.openxmlformats.org/presentationml/2006/main" xmlns:r="http://schemas.openxmlformats.org/officeDocument/2006/relationships">
+<p:sld xmlns:a="http://schemas.openxmlformats.org/drawingml/2006/main" xmlns:r="http://schemas.openxmlformats.org/officeDocument/2006/relationships" xmlns:p="http://schemas.openxmlformats.org/presentationml/2006/main">
   <p:cSld>
     <p:spTree>
       <p:nvGrpSpPr>
@@ -9492,7 +9427,7 @@
 </file>
 
 <file path=ppt/slides/slide9.xml><?xml version="1.0" encoding="utf-8"?>
-<p:sld xmlns:a="http://schemas.openxmlformats.org/drawingml/2006/main" xmlns:p="http://schemas.openxmlformats.org/presentationml/2006/main" xmlns:r="http://schemas.openxmlformats.org/officeDocument/2006/relationships">
+<p:sld xmlns:a="http://schemas.openxmlformats.org/drawingml/2006/main" xmlns:r="http://schemas.openxmlformats.org/officeDocument/2006/relationships" xmlns:p="http://schemas.openxmlformats.org/presentationml/2006/main">
   <p:cSld>
     <p:spTree>
       <p:nvGrpSpPr>
@@ -10365,6 +10300,10 @@
       </a:style>
     </a:lnDef>
   </a:objectDefaults>
-  <a:extraClrSchemeLst/>
+  <a:extLst>
+    <a:ext uri="{05A4C25C-085E-4340-85A3-A5531E510DB2}">
+      <thm15:themeFamily xmlns:thm15="http://schemas.microsoft.com/office/thememl/2012/main" name="Office Theme" id="{62F939B6-93AF-4DB8-9C6B-D6C7DFDC589F}" vid="{4A3C46E8-61CC-4603-A589-7422A47A8E4A}"/>
+    </a:ext>
+  </a:extLst>
 </a:theme>
 </file>
</xml_diff>